<commit_message>
docs: translate presentation to portuguese
</commit_message>
<xml_diff>
--- a/apresentacao-roboflux.pptx
+++ b/apresentacao-roboflux.pptx
@@ -3122,6 +3122,11 @@
           <a:solidFill>
             <a:srgbClr val="B8C398"/>
           </a:solidFill>
+          <a:ln>
+            <a:solidFill>
+              <a:srgbClr val="B8C398"/>
+            </a:solidFill>
+          </a:ln>
         </p:spPr>
         <p:style>
           <a:lnRef idx="1">
@@ -3162,7 +3167,7 @@
           <a:noFill/>
         </p:spPr>
         <p:txBody>
-          <a:bodyPr wrap="none">
+          <a:bodyPr wrap="square">
             <a:spAutoFit/>
           </a:bodyPr>
           <a:lstStyle/>
@@ -3188,8 +3193,8 @@
         </p:nvSpPr>
         <p:spPr>
           <a:xfrm>
-            <a:off x="777240" y="1417320"/>
-            <a:ext cx="10424160" cy="1143000"/>
+            <a:off x="777240" y="1325880"/>
+            <a:ext cx="10607040" cy="1234440"/>
           </a:xfrm>
           <a:prstGeom prst="rect">
             <a:avLst/>
@@ -3197,20 +3202,20 @@
           <a:noFill/>
         </p:spPr>
         <p:txBody>
-          <a:bodyPr wrap="none">
+          <a:bodyPr wrap="square">
             <a:spAutoFit/>
           </a:bodyPr>
           <a:lstStyle/>
           <a:p>
             <a:pPr algn="l"/>
             <a:r>
-              <a:rPr sz="4200" b="1">
+              <a:rPr sz="3900" b="1">
                 <a:solidFill>
                   <a:srgbClr val="273138"/>
                 </a:solidFill>
                 <a:latin typeface="Aptos"/>
               </a:rPr>
-              <a:t>Reactive AGV Path Planning</a:t>
+              <a:t>Planeamento reativo de rota para um AGV industrial</a:t>
             </a:r>
           </a:p>
         </p:txBody>
@@ -3223,8 +3228,8 @@
         </p:nvSpPr>
         <p:spPr>
           <a:xfrm>
-            <a:off x="822960" y="2788920"/>
-            <a:ext cx="9784080" cy="640080"/>
+            <a:off x="822960" y="2816352"/>
+            <a:ext cx="9875520" cy="640080"/>
           </a:xfrm>
           <a:prstGeom prst="rect">
             <a:avLst/>
@@ -3232,7 +3237,7 @@
           <a:noFill/>
         </p:spPr>
         <p:txBody>
-          <a:bodyPr wrap="none">
+          <a:bodyPr wrap="square">
             <a:spAutoFit/>
           </a:bodyPr>
           <a:lstStyle/>
@@ -3245,7 +3250,7 @@
                 </a:solidFill>
                 <a:latin typeface="Aptos"/>
               </a:rPr>
-              <a:t>A web project that connects structured programming with Robotics and Industrial Automation.</a:t>
+              <a:t>Projeto web sobre Robótica e Automação Industrial com algoritmo A*.</a:t>
             </a:r>
           </a:p>
         </p:txBody>
@@ -3258,7 +3263,7 @@
         </p:nvSpPr>
         <p:spPr>
           <a:xfrm>
-            <a:off x="822960" y="3931920"/>
+            <a:off x="822960" y="3886200"/>
             <a:ext cx="3749039" cy="502920"/>
           </a:xfrm>
           <a:prstGeom prst="roundRect">
@@ -3299,7 +3304,7 @@
                 </a:solidFill>
                 <a:latin typeface="Aptos"/>
               </a:rPr>
-              <a:t>Robotics · Automation · Algorithms</a:t>
+              <a:t>Robótica · Automação · Algoritmos</a:t>
             </a:r>
           </a:p>
         </p:txBody>
@@ -3321,7 +3326,7 @@
           <a:noFill/>
         </p:spPr>
         <p:txBody>
-          <a:bodyPr wrap="none">
+          <a:bodyPr wrap="square">
             <a:spAutoFit/>
           </a:bodyPr>
           <a:lstStyle/>
@@ -3356,7 +3361,7 @@
           <a:noFill/>
         </p:spPr>
         <p:txBody>
-          <a:bodyPr wrap="none">
+          <a:bodyPr wrap="square">
             <a:spAutoFit/>
           </a:bodyPr>
           <a:lstStyle/>
@@ -3409,7 +3414,7 @@
         <p:spPr>
           <a:xfrm>
             <a:off x="685800" y="411480"/>
-            <a:ext cx="10698480" cy="548640"/>
+            <a:ext cx="10698480" cy="594360"/>
           </a:xfrm>
           <a:prstGeom prst="rect">
             <a:avLst/>
@@ -3417,7 +3422,7 @@
           <a:noFill/>
         </p:spPr>
         <p:txBody>
-          <a:bodyPr wrap="none">
+          <a:bodyPr wrap="square">
             <a:spAutoFit/>
           </a:bodyPr>
           <a:lstStyle/>
@@ -3430,7 +3435,7 @@
                 </a:solidFill>
                 <a:latin typeface="Aptos"/>
               </a:rPr>
-              <a:t>Conclusion and links</a:t>
+              <a:t>Conclusão e links</a:t>
             </a:r>
           </a:p>
         </p:txBody>
@@ -3444,7 +3449,7 @@
         <p:spPr>
           <a:xfrm>
             <a:off x="868680" y="1371600"/>
-            <a:ext cx="9875520" cy="640080"/>
+            <a:ext cx="9875520" cy="777240"/>
           </a:xfrm>
           <a:prstGeom prst="rect">
             <a:avLst/>
@@ -3452,20 +3457,20 @@
           <a:noFill/>
         </p:spPr>
         <p:txBody>
-          <a:bodyPr wrap="none">
+          <a:bodyPr wrap="square">
             <a:spAutoFit/>
           </a:bodyPr>
           <a:lstStyle/>
           <a:p>
             <a:pPr algn="l"/>
             <a:r>
-              <a:rPr sz="2800" b="1">
+              <a:rPr sz="2700" b="1">
                 <a:solidFill>
                   <a:srgbClr val="273138"/>
                 </a:solidFill>
                 <a:latin typeface="Aptos"/>
               </a:rPr>
-              <a:t>RoboFlux turns programming concepts into a practical automation simulation.</a:t>
+              <a:t>O RoboFlux transforma conceitos de programação numa simulação prática de automação.</a:t>
             </a:r>
           </a:p>
         </p:txBody>
@@ -3504,7 +3509,7 @@
               </a:defRPr>
             </a:pPr>
             <a:r>
-              <a:t>Website: https://roboflux-robotica.pages.dev/</a:t>
+              <a:t>Site: https://roboflux-robotica.pages.dev/</a:t>
             </a:r>
           </a:p>
           <a:p>
@@ -3520,7 +3525,7 @@
               </a:defRPr>
             </a:pPr>
             <a:r>
-              <a:t>Report: https://roboflux-robotica.pages.dev/relatorio.pdf</a:t>
+              <a:t>Relatório: https://roboflux-robotica.pages.dev/relatorio.pdf</a:t>
             </a:r>
           </a:p>
           <a:p>
@@ -3550,7 +3555,7 @@
         <p:spPr>
           <a:xfrm>
             <a:off x="868680" y="5166360"/>
-            <a:ext cx="7315200" cy="594360"/>
+            <a:ext cx="6858000" cy="594360"/>
           </a:xfrm>
           <a:prstGeom prst="roundRect">
             <a:avLst/>
@@ -3590,7 +3595,7 @@
                 </a:solidFill>
                 <a:latin typeface="Aptos"/>
               </a:rPr>
-              <a:t>Call to action: visit the page and run the AGV simulation.</a:t>
+              <a:t>Chamada: visitar a página e executar a simulação do AGV.</a:t>
             </a:r>
           </a:p>
         </p:txBody>
@@ -3612,7 +3617,7 @@
           <a:noFill/>
         </p:spPr>
         <p:txBody>
-          <a:bodyPr wrap="none">
+          <a:bodyPr wrap="square">
             <a:spAutoFit/>
           </a:bodyPr>
           <a:lstStyle/>
@@ -3665,7 +3670,7 @@
         <p:spPr>
           <a:xfrm>
             <a:off x="685800" y="411480"/>
-            <a:ext cx="10698480" cy="548640"/>
+            <a:ext cx="10698480" cy="594360"/>
           </a:xfrm>
           <a:prstGeom prst="rect">
             <a:avLst/>
@@ -3673,7 +3678,7 @@
           <a:noFill/>
         </p:spPr>
         <p:txBody>
-          <a:bodyPr wrap="none">
+          <a:bodyPr wrap="square">
             <a:spAutoFit/>
           </a:bodyPr>
           <a:lstStyle/>
@@ -3686,7 +3691,7 @@
                 </a:solidFill>
                 <a:latin typeface="Aptos"/>
               </a:rPr>
-              <a:t>Project objective</a:t>
+              <a:t>Objetivo do projeto</a:t>
             </a:r>
           </a:p>
         </p:txBody>
@@ -3699,7 +3704,7 @@
         </p:nvSpPr>
         <p:spPr>
           <a:xfrm>
-            <a:off x="713232" y="1024128"/>
+            <a:off x="713232" y="1051560"/>
             <a:ext cx="10241280" cy="411480"/>
           </a:xfrm>
           <a:prstGeom prst="rect">
@@ -3708,7 +3713,7 @@
           <a:noFill/>
         </p:spPr>
         <p:txBody>
-          <a:bodyPr wrap="none">
+          <a:bodyPr wrap="square">
             <a:spAutoFit/>
           </a:bodyPr>
           <a:lstStyle/>
@@ -3721,7 +3726,7 @@
                 </a:solidFill>
                 <a:latin typeface="Aptos"/>
               </a:rPr>
-              <a:t>The project solves a small but realistic automation problem.</a:t>
+              <a:t>Resolver um problema simples, mas realista, da automação industrial.</a:t>
             </a:r>
           </a:p>
         </p:txBody>
@@ -3734,8 +3739,8 @@
         </p:nvSpPr>
         <p:spPr>
           <a:xfrm>
-            <a:off x="868680" y="1737360"/>
-            <a:ext cx="7680960" cy="3200400"/>
+            <a:off x="868680" y="1600200"/>
+            <a:ext cx="8412480" cy="3749039"/>
           </a:xfrm>
           <a:prstGeom prst="rect">
             <a:avLst/>
@@ -3752,7 +3757,7 @@
               <a:spcAft>
                 <a:spcPts val="800"/>
               </a:spcAft>
-              <a:defRPr sz="2200">
+              <a:defRPr sz="2100">
                 <a:solidFill>
                   <a:srgbClr val="273138"/>
                 </a:solidFill>
@@ -3760,7 +3765,7 @@
               </a:defRPr>
             </a:pPr>
             <a:r>
-              <a:t>Build an interactive web application related to the course area.</a:t>
+              <a:t>Criar uma aplicação web interativa ligada à área do curso.</a:t>
             </a:r>
           </a:p>
           <a:p>
@@ -3768,7 +3773,7 @@
               <a:spcAft>
                 <a:spcPts val="800"/>
               </a:spcAft>
-              <a:defRPr sz="2200">
+              <a:defRPr sz="2100">
                 <a:solidFill>
                   <a:srgbClr val="273138"/>
                 </a:solidFill>
@@ -3776,7 +3781,7 @@
               </a:defRPr>
             </a:pPr>
             <a:r>
-              <a:t>Use programming fundamentals: variables, conditionals, loops, functions and DOM manipulation.</a:t>
+              <a:t>Aplicar HTML, CSS e JavaScript de forma prática.</a:t>
             </a:r>
           </a:p>
           <a:p>
@@ -3784,7 +3789,7 @@
               <a:spcAft>
                 <a:spcPts val="800"/>
               </a:spcAft>
-              <a:defRPr sz="2200">
+              <a:defRPr sz="2100">
                 <a:solidFill>
                   <a:srgbClr val="273138"/>
                 </a:solidFill>
@@ -3792,7 +3797,7 @@
               </a:defRPr>
             </a:pPr>
             <a:r>
-              <a:t>Simulate how an AGV calculates a safe route inside a factory floor.</a:t>
+              <a:t>Usar variáveis, condicionais, ciclos, funções e manipulação do DOM.</a:t>
             </a:r>
           </a:p>
           <a:p>
@@ -3800,7 +3805,7 @@
               <a:spcAft>
                 <a:spcPts val="800"/>
               </a:spcAft>
-              <a:defRPr sz="2200">
+              <a:defRPr sz="2100">
                 <a:solidFill>
                   <a:srgbClr val="273138"/>
                 </a:solidFill>
@@ -3808,7 +3813,23 @@
               </a:defRPr>
             </a:pPr>
             <a:r>
-              <a:t>Explain the logic clearly enough to present it, not just show the final page.</a:t>
+              <a:t>Simular como um AGV calcula uma rota segura dentro de uma fábrica.</a:t>
+            </a:r>
+          </a:p>
+          <a:p>
+            <a:pPr>
+              <a:spcAft>
+                <a:spcPts val="800"/>
+              </a:spcAft>
+              <a:defRPr sz="2100">
+                <a:solidFill>
+                  <a:srgbClr val="273138"/>
+                </a:solidFill>
+                <a:latin typeface="Aptos"/>
+              </a:defRPr>
+            </a:pPr>
+            <a:r>
+              <a:t>Explicar a lógica do algoritmo, não apenas mostrar uma página bonita.</a:t>
             </a:r>
           </a:p>
         </p:txBody>
@@ -3821,8 +3842,8 @@
         </p:nvSpPr>
         <p:spPr>
           <a:xfrm>
-            <a:off x="868680" y="5349240"/>
-            <a:ext cx="6583680" cy="502920"/>
+            <a:off x="868680" y="5532120"/>
+            <a:ext cx="6766560" cy="502920"/>
           </a:xfrm>
           <a:prstGeom prst="roundRect">
             <a:avLst/>
@@ -3862,7 +3883,7 @@
                 </a:solidFill>
                 <a:latin typeface="Aptos"/>
               </a:rPr>
-              <a:t>Key idea: code is used to explain a real industrial process.</a:t>
+              <a:t>Ideia principal: programação aplicada a um processo industrial.</a:t>
             </a:r>
           </a:p>
         </p:txBody>
@@ -3884,7 +3905,7 @@
           <a:noFill/>
         </p:spPr>
         <p:txBody>
-          <a:bodyPr wrap="none">
+          <a:bodyPr wrap="square">
             <a:spAutoFit/>
           </a:bodyPr>
           <a:lstStyle/>
@@ -3937,7 +3958,7 @@
         <p:spPr>
           <a:xfrm>
             <a:off x="685800" y="411480"/>
-            <a:ext cx="10698480" cy="548640"/>
+            <a:ext cx="10698480" cy="594360"/>
           </a:xfrm>
           <a:prstGeom prst="rect">
             <a:avLst/>
@@ -3945,7 +3966,7 @@
           <a:noFill/>
         </p:spPr>
         <p:txBody>
-          <a:bodyPr wrap="none">
+          <a:bodyPr wrap="square">
             <a:spAutoFit/>
           </a:bodyPr>
           <a:lstStyle/>
@@ -3958,7 +3979,7 @@
                 </a:solidFill>
                 <a:latin typeface="Aptos"/>
               </a:rPr>
-              <a:t>Why this fits Robotics and Industrial Automation</a:t>
+              <a:t>Ligação à Robótica e Automação Industrial</a:t>
             </a:r>
           </a:p>
         </p:txBody>
@@ -3971,7 +3992,7 @@
         </p:nvSpPr>
         <p:spPr>
           <a:xfrm>
-            <a:off x="713232" y="1024128"/>
+            <a:off x="713232" y="1051560"/>
             <a:ext cx="10241280" cy="411480"/>
           </a:xfrm>
           <a:prstGeom prst="rect">
@@ -3980,7 +4001,7 @@
           <a:noFill/>
         </p:spPr>
         <p:txBody>
-          <a:bodyPr wrap="none">
+          <a:bodyPr wrap="square">
             <a:spAutoFit/>
           </a:bodyPr>
           <a:lstStyle/>
@@ -3993,7 +4014,7 @@
                 </a:solidFill>
                 <a:latin typeface="Aptos"/>
               </a:rPr>
-              <a:t>Industrial environments change. A robot must react.</a:t>
+              <a:t>Numa fábrica, o ambiente muda. Um robô tem de reagir.</a:t>
             </a:r>
           </a:p>
         </p:txBody>
@@ -4006,8 +4027,8 @@
         </p:nvSpPr>
         <p:spPr>
           <a:xfrm>
-            <a:off x="868680" y="1691640"/>
-            <a:ext cx="7223760" cy="3291840"/>
+            <a:off x="868680" y="1600200"/>
+            <a:ext cx="7040880" cy="3291840"/>
           </a:xfrm>
           <a:prstGeom prst="rect">
             <a:avLst/>
@@ -4024,7 +4045,7 @@
               <a:spcAft>
                 <a:spcPts val="800"/>
               </a:spcAft>
-              <a:defRPr sz="2200">
+              <a:defRPr sz="2100">
                 <a:solidFill>
                   <a:srgbClr val="273138"/>
                 </a:solidFill>
@@ -4032,7 +4053,7 @@
               </a:defRPr>
             </a:pPr>
             <a:r>
-              <a:t>A factory floor can contain machines, pallets, blocked zones and moving obstacles.</a:t>
+              <a:t>O AGV pode encontrar máquinas, paletes, pessoas ou zonas bloqueadas.</a:t>
             </a:r>
           </a:p>
           <a:p>
@@ -4040,7 +4061,7 @@
               <a:spcAft>
                 <a:spcPts val="800"/>
               </a:spcAft>
-              <a:defRPr sz="2200">
+              <a:defRPr sz="2100">
                 <a:solidFill>
                   <a:srgbClr val="273138"/>
                 </a:solidFill>
@@ -4048,7 +4069,7 @@
               </a:defRPr>
             </a:pPr>
             <a:r>
-              <a:t>An AGV should not depend on one fixed path only.</a:t>
+              <a:t>O caminho nem sempre deve ser fixo ou decorado.</a:t>
             </a:r>
           </a:p>
           <a:p>
@@ -4056,7 +4077,7 @@
               <a:spcAft>
                 <a:spcPts val="800"/>
               </a:spcAft>
-              <a:defRPr sz="2200">
+              <a:defRPr sz="2100">
                 <a:solidFill>
                   <a:srgbClr val="273138"/>
                 </a:solidFill>
@@ -4064,7 +4085,7 @@
               </a:defRPr>
             </a:pPr>
             <a:r>
-              <a:t>The map represents a simplified factory floor using a 10x10 grid.</a:t>
+              <a:t>A grelha 10x10 representa uma versão simplificada do chão da fábrica.</a:t>
             </a:r>
           </a:p>
           <a:p>
@@ -4072,7 +4093,7 @@
               <a:spcAft>
                 <a:spcPts val="800"/>
               </a:spcAft>
-              <a:defRPr sz="2200">
+              <a:defRPr sz="2100">
                 <a:solidFill>
                   <a:srgbClr val="273138"/>
                 </a:solidFill>
@@ -4080,7 +4101,7 @@
               </a:defRPr>
             </a:pPr>
             <a:r>
-              <a:t>The algorithm recalculates the route when the map changes.</a:t>
+              <a:t>Quando o mapa muda, o algoritmo volta a calcular uma rota possível.</a:t>
             </a:r>
           </a:p>
         </p:txBody>
@@ -5174,7 +5195,7 @@
         <p:spPr>
           <a:xfrm>
             <a:off x="8229600" y="3840480"/>
-            <a:ext cx="2834640" cy="365760"/>
+            <a:ext cx="3017520" cy="365760"/>
           </a:xfrm>
           <a:prstGeom prst="rect">
             <a:avLst/>
@@ -5182,7 +5203,7 @@
           <a:noFill/>
         </p:spPr>
         <p:txBody>
-          <a:bodyPr wrap="none">
+          <a:bodyPr wrap="square">
             <a:spAutoFit/>
           </a:bodyPr>
           <a:lstStyle/>
@@ -5195,7 +5216,7 @@
                 </a:solidFill>
                 <a:latin typeface="Aptos"/>
               </a:rPr>
-              <a:t>Simplified AGV grid</a:t>
+              <a:t>Grelha simplificada do AGV</a:t>
             </a:r>
           </a:p>
         </p:txBody>
@@ -5217,7 +5238,7 @@
           <a:noFill/>
         </p:spPr>
         <p:txBody>
-          <a:bodyPr wrap="none">
+          <a:bodyPr wrap="square">
             <a:spAutoFit/>
           </a:bodyPr>
           <a:lstStyle/>
@@ -5270,7 +5291,7 @@
         <p:spPr>
           <a:xfrm>
             <a:off x="685800" y="411480"/>
-            <a:ext cx="10698480" cy="548640"/>
+            <a:ext cx="10698480" cy="594360"/>
           </a:xfrm>
           <a:prstGeom prst="rect">
             <a:avLst/>
@@ -5278,7 +5299,7 @@
           <a:noFill/>
         </p:spPr>
         <p:txBody>
-          <a:bodyPr wrap="none">
+          <a:bodyPr wrap="square">
             <a:spAutoFit/>
           </a:bodyPr>
           <a:lstStyle/>
@@ -5291,7 +5312,7 @@
                 </a:solidFill>
                 <a:latin typeface="Aptos"/>
               </a:rPr>
-              <a:t>How the user interacts with the page</a:t>
+              <a:t>Como funciona na página</a:t>
             </a:r>
           </a:p>
         </p:txBody>
@@ -5330,7 +5351,7 @@
               </a:defRPr>
             </a:pPr>
             <a:r>
-              <a:t>Open the RoboFlux website.</a:t>
+              <a:t>O utilizador abre o site RoboFlux.</a:t>
             </a:r>
           </a:p>
           <a:p>
@@ -5346,7 +5367,7 @@
               </a:defRPr>
             </a:pPr>
             <a:r>
-              <a:t>Look at the AGV grid simulation.</a:t>
+              <a:t>A secção principal mostra uma grelha com início, destino e obstáculos.</a:t>
             </a:r>
           </a:p>
           <a:p>
@@ -5362,7 +5383,7 @@
               </a:defRPr>
             </a:pPr>
             <a:r>
-              <a:t>Click “Generate new map” to create a different valid factory layout.</a:t>
+              <a:t>O botão “Gerar novo mapa” cria um problema diferente.</a:t>
             </a:r>
           </a:p>
           <a:p>
@@ -5378,7 +5399,7 @@
               </a:defRPr>
             </a:pPr>
             <a:r>
-              <a:t>Click “Run algorithm” to watch A* analyse cells and find the route.</a:t>
+              <a:t>O botão “Executar algoritmo” mostra o A* a analisar células.</a:t>
             </a:r>
           </a:p>
           <a:p>
@@ -5394,7 +5415,7 @@
               </a:defRPr>
             </a:pPr>
             <a:r>
-              <a:t>Read the explanation sections to understand what is happening.</a:t>
+              <a:t>No fim, a rota encontrada aparece destacada no mapa.</a:t>
             </a:r>
           </a:p>
         </p:txBody>
@@ -5408,7 +5429,7 @@
         <p:spPr>
           <a:xfrm>
             <a:off x="868680" y="5532120"/>
-            <a:ext cx="5029200" cy="502920"/>
+            <a:ext cx="6766560" cy="502920"/>
           </a:xfrm>
           <a:prstGeom prst="roundRect">
             <a:avLst/>
@@ -5448,7 +5469,7 @@
                 </a:solidFill>
                 <a:latin typeface="Aptos"/>
               </a:rPr>
-              <a:t>The page is interactive, not just informational.</a:t>
+              <a:t>A página é interativa: o utilizador vê o algoritmo a trabalhar.</a:t>
             </a:r>
           </a:p>
         </p:txBody>
@@ -5470,7 +5491,7 @@
           <a:noFill/>
         </p:spPr>
         <p:txBody>
-          <a:bodyPr wrap="none">
+          <a:bodyPr wrap="square">
             <a:spAutoFit/>
           </a:bodyPr>
           <a:lstStyle/>
@@ -5523,7 +5544,7 @@
         <p:spPr>
           <a:xfrm>
             <a:off x="685800" y="411480"/>
-            <a:ext cx="10698480" cy="548640"/>
+            <a:ext cx="10698480" cy="594360"/>
           </a:xfrm>
           <a:prstGeom prst="rect">
             <a:avLst/>
@@ -5531,7 +5552,7 @@
           <a:noFill/>
         </p:spPr>
         <p:txBody>
-          <a:bodyPr wrap="none">
+          <a:bodyPr wrap="square">
             <a:spAutoFit/>
           </a:bodyPr>
           <a:lstStyle/>
@@ -5544,7 +5565,7 @@
                 </a:solidFill>
                 <a:latin typeface="Aptos"/>
               </a:rPr>
-              <a:t>The A* algorithm</a:t>
+              <a:t>O algoritmo A*</a:t>
             </a:r>
           </a:p>
         </p:txBody>
@@ -5557,7 +5578,7 @@
         </p:nvSpPr>
         <p:spPr>
           <a:xfrm>
-            <a:off x="713232" y="1024128"/>
+            <a:off x="713232" y="1051560"/>
             <a:ext cx="10241280" cy="411480"/>
           </a:xfrm>
           <a:prstGeom prst="rect">
@@ -5566,7 +5587,7 @@
           <a:noFill/>
         </p:spPr>
         <p:txBody>
-          <a:bodyPr wrap="none">
+          <a:bodyPr wrap="square">
             <a:spAutoFit/>
           </a:bodyPr>
           <a:lstStyle/>
@@ -5579,7 +5600,7 @@
                 </a:solidFill>
                 <a:latin typeface="Aptos"/>
               </a:rPr>
-              <a:t>A* finds a path by balancing real cost and estimated distance.</a:t>
+              <a:t>O A* encontra caminhos juntando custo real e estimativa.</a:t>
             </a:r>
           </a:p>
         </p:txBody>
@@ -5601,7 +5622,7 @@
           <a:noFill/>
         </p:spPr>
         <p:txBody>
-          <a:bodyPr wrap="none">
+          <a:bodyPr wrap="square">
             <a:spAutoFit/>
           </a:bodyPr>
           <a:lstStyle/>
@@ -5653,7 +5674,7 @@
               </a:defRPr>
             </a:pPr>
             <a:r>
-              <a:t>g = cost already travelled</a:t>
+              <a:t>g = custo real já percorrido</a:t>
             </a:r>
           </a:p>
           <a:p>
@@ -5669,7 +5690,7 @@
               </a:defRPr>
             </a:pPr>
             <a:r>
-              <a:t>h = estimated distance to the destination</a:t>
+              <a:t>h = estimativa da distância até ao destino</a:t>
             </a:r>
           </a:p>
           <a:p>
@@ -5685,7 +5706,7 @@
               </a:defRPr>
             </a:pPr>
             <a:r>
-              <a:t>f = total priority used to choose the next cell</a:t>
+              <a:t>f = prioridade usada para escolher a próxima célula</a:t>
             </a:r>
           </a:p>
         </p:txBody>
@@ -5707,7 +5728,7 @@
           <a:noFill/>
         </p:spPr>
         <p:txBody>
-          <a:bodyPr wrap="none">
+          <a:bodyPr wrap="square">
             <a:spAutoFit/>
           </a:bodyPr>
           <a:lstStyle/>
@@ -5720,7 +5741,7 @@
                 </a:solidFill>
                 <a:latin typeface="Aptos"/>
               </a:rPr>
-              <a:t>Simple explanation</a:t>
+              <a:t>Explicação simples</a:t>
             </a:r>
           </a:p>
         </p:txBody>
@@ -5759,7 +5780,7 @@
               </a:defRPr>
             </a:pPr>
             <a:r>
-              <a:t>The AGV looks at nearby cells.</a:t>
+              <a:t>O AGV olha para as células à volta.</a:t>
             </a:r>
           </a:p>
           <a:p>
@@ -5775,7 +5796,7 @@
               </a:defRPr>
             </a:pPr>
             <a:r>
-              <a:t>It avoids blocked cells.</a:t>
+              <a:t>Evita as células bloqueadas.</a:t>
             </a:r>
           </a:p>
           <a:p>
@@ -5791,7 +5812,7 @@
               </a:defRPr>
             </a:pPr>
             <a:r>
-              <a:t>It chooses the most promising option.</a:t>
+              <a:t>Escolhe a opção mais promissora.</a:t>
             </a:r>
           </a:p>
           <a:p>
@@ -5807,7 +5828,7 @@
               </a:defRPr>
             </a:pPr>
             <a:r>
-              <a:t>It repeats until it reaches the destination.</a:t>
+              <a:t>Repete até chegar ao destino.</a:t>
             </a:r>
           </a:p>
         </p:txBody>
@@ -5829,7 +5850,7 @@
           <a:noFill/>
         </p:spPr>
         <p:txBody>
-          <a:bodyPr wrap="none">
+          <a:bodyPr wrap="square">
             <a:spAutoFit/>
           </a:bodyPr>
           <a:lstStyle/>
@@ -5882,7 +5903,7 @@
         <p:spPr>
           <a:xfrm>
             <a:off x="685800" y="411480"/>
-            <a:ext cx="10698480" cy="548640"/>
+            <a:ext cx="10698480" cy="594360"/>
           </a:xfrm>
           <a:prstGeom prst="rect">
             <a:avLst/>
@@ -5890,7 +5911,7 @@
           <a:noFill/>
         </p:spPr>
         <p:txBody>
-          <a:bodyPr wrap="none">
+          <a:bodyPr wrap="square">
             <a:spAutoFit/>
           </a:bodyPr>
           <a:lstStyle/>
@@ -5903,7 +5924,7 @@
                 </a:solidFill>
                 <a:latin typeface="Aptos"/>
               </a:rPr>
-              <a:t>Controlled randomness</a:t>
+              <a:t>Mapa aleatório, mas controlado</a:t>
             </a:r>
           </a:p>
         </p:txBody>
@@ -5916,7 +5937,7 @@
         </p:nvSpPr>
         <p:spPr>
           <a:xfrm>
-            <a:off x="713232" y="1024128"/>
+            <a:off x="713232" y="1051560"/>
             <a:ext cx="10241280" cy="411480"/>
           </a:xfrm>
           <a:prstGeom prst="rect">
@@ -5925,7 +5946,7 @@
           <a:noFill/>
         </p:spPr>
         <p:txBody>
-          <a:bodyPr wrap="none">
+          <a:bodyPr wrap="square">
             <a:spAutoFit/>
           </a:bodyPr>
           <a:lstStyle/>
@@ -5938,7 +5959,7 @@
                 </a:solidFill>
                 <a:latin typeface="Aptos"/>
               </a:rPr>
-              <a:t>Random does not mean chaotic.</a:t>
+              <a:t>Aleatório não significa sem regras.</a:t>
             </a:r>
           </a:p>
         </p:txBody>
@@ -5977,7 +5998,7 @@
               </a:defRPr>
             </a:pPr>
             <a:r>
-              <a:t>The map generator creates random obstacles.</a:t>
+              <a:t>O sistema gera obstáculos aleatórios.</a:t>
             </a:r>
           </a:p>
           <a:p>
@@ -5993,7 +6014,7 @@
               </a:defRPr>
             </a:pPr>
             <a:r>
-              <a:t>Before showing the map, the system checks if a route still exists.</a:t>
+              <a:t>Antes de mostrar o mapa, confirma se ainda existe caminho.</a:t>
             </a:r>
           </a:p>
           <a:p>
@@ -6009,7 +6030,7 @@
               </a:defRPr>
             </a:pPr>
             <a:r>
-              <a:t>If the map is impossible, it tries again.</a:t>
+              <a:t>Se o mapa for impossível, tenta gerar outro.</a:t>
             </a:r>
           </a:p>
           <a:p>
@@ -6025,7 +6046,7 @@
               </a:defRPr>
             </a:pPr>
             <a:r>
-              <a:t>This makes the project dynamic while keeping the simulation useful.</a:t>
+              <a:t>Assim a simulação fica dinâmica, mas continua útil e explicável.</a:t>
             </a:r>
           </a:p>
         </p:txBody>
@@ -6039,7 +6060,7 @@
         <p:spPr>
           <a:xfrm>
             <a:off x="868680" y="5074920"/>
-            <a:ext cx="5394960" cy="502920"/>
+            <a:ext cx="6217920" cy="502920"/>
           </a:xfrm>
           <a:prstGeom prst="roundRect">
             <a:avLst/>
@@ -6079,7 +6100,7 @@
                 </a:solidFill>
                 <a:latin typeface="Aptos"/>
               </a:rPr>
-              <a:t>Dynamic + valid = better learning experience</a:t>
+              <a:t>Dinâmico + válido = melhor experiência de aprendizagem.</a:t>
             </a:r>
           </a:p>
         </p:txBody>
@@ -6101,7 +6122,7 @@
           <a:noFill/>
         </p:spPr>
         <p:txBody>
-          <a:bodyPr wrap="none">
+          <a:bodyPr wrap="square">
             <a:spAutoFit/>
           </a:bodyPr>
           <a:lstStyle/>
@@ -6154,7 +6175,7 @@
         <p:spPr>
           <a:xfrm>
             <a:off x="685800" y="411480"/>
-            <a:ext cx="10698480" cy="548640"/>
+            <a:ext cx="10698480" cy="594360"/>
           </a:xfrm>
           <a:prstGeom prst="rect">
             <a:avLst/>
@@ -6162,7 +6183,7 @@
           <a:noFill/>
         </p:spPr>
         <p:txBody>
-          <a:bodyPr wrap="none">
+          <a:bodyPr wrap="square">
             <a:spAutoFit/>
           </a:bodyPr>
           <a:lstStyle/>
@@ -6175,7 +6196,7 @@
                 </a:solidFill>
                 <a:latin typeface="Aptos"/>
               </a:rPr>
-              <a:t>Technologies used</a:t>
+              <a:t>Tecnologias utilizadas</a:t>
             </a:r>
           </a:p>
         </p:txBody>
@@ -6234,7 +6255,7 @@
         <p:spPr>
           <a:xfrm>
             <a:off x="1005840" y="1581912"/>
-            <a:ext cx="2194560" cy="274320"/>
+            <a:ext cx="2560320" cy="274320"/>
           </a:xfrm>
           <a:prstGeom prst="rect">
             <a:avLst/>
@@ -6242,7 +6263,7 @@
           <a:noFill/>
         </p:spPr>
         <p:txBody>
-          <a:bodyPr wrap="none">
+          <a:bodyPr wrap="square">
             <a:spAutoFit/>
           </a:bodyPr>
           <a:lstStyle/>
@@ -6269,7 +6290,7 @@
         <p:spPr>
           <a:xfrm>
             <a:off x="1005840" y="1920240"/>
-            <a:ext cx="4297680" cy="274320"/>
+            <a:ext cx="4389120" cy="274320"/>
           </a:xfrm>
           <a:prstGeom prst="rect">
             <a:avLst/>
@@ -6277,7 +6298,7 @@
           <a:noFill/>
         </p:spPr>
         <p:txBody>
-          <a:bodyPr wrap="none">
+          <a:bodyPr wrap="square">
             <a:spAutoFit/>
           </a:bodyPr>
           <a:lstStyle/>
@@ -6290,7 +6311,7 @@
                 </a:solidFill>
                 <a:latin typeface="Aptos"/>
               </a:rPr>
-              <a:t>component structure</a:t>
+              <a:t>organização por componentes</a:t>
             </a:r>
           </a:p>
         </p:txBody>
@@ -6349,7 +6370,7 @@
         <p:spPr>
           <a:xfrm>
             <a:off x="6583679" y="1581912"/>
-            <a:ext cx="2194560" cy="274320"/>
+            <a:ext cx="2560320" cy="274320"/>
           </a:xfrm>
           <a:prstGeom prst="rect">
             <a:avLst/>
@@ -6357,7 +6378,7 @@
           <a:noFill/>
         </p:spPr>
         <p:txBody>
-          <a:bodyPr wrap="none">
+          <a:bodyPr wrap="square">
             <a:spAutoFit/>
           </a:bodyPr>
           <a:lstStyle/>
@@ -6384,7 +6405,7 @@
         <p:spPr>
           <a:xfrm>
             <a:off x="6583679" y="1920240"/>
-            <a:ext cx="4297680" cy="274320"/>
+            <a:ext cx="4389120" cy="274320"/>
           </a:xfrm>
           <a:prstGeom prst="rect">
             <a:avLst/>
@@ -6392,7 +6413,7 @@
           <a:noFill/>
         </p:spPr>
         <p:txBody>
-          <a:bodyPr wrap="none">
+          <a:bodyPr wrap="square">
             <a:spAutoFit/>
           </a:bodyPr>
           <a:lstStyle/>
@@ -6405,7 +6426,7 @@
                 </a:solidFill>
                 <a:latin typeface="Aptos"/>
               </a:rPr>
-              <a:t>page structure</a:t>
+              <a:t>estrutura da página</a:t>
             </a:r>
           </a:p>
         </p:txBody>
@@ -6464,7 +6485,7 @@
         <p:spPr>
           <a:xfrm>
             <a:off x="1005840" y="2907792"/>
-            <a:ext cx="2194560" cy="274320"/>
+            <a:ext cx="2560320" cy="274320"/>
           </a:xfrm>
           <a:prstGeom prst="rect">
             <a:avLst/>
@@ -6472,7 +6493,7 @@
           <a:noFill/>
         </p:spPr>
         <p:txBody>
-          <a:bodyPr wrap="none">
+          <a:bodyPr wrap="square">
             <a:spAutoFit/>
           </a:bodyPr>
           <a:lstStyle/>
@@ -6499,7 +6520,7 @@
         <p:spPr>
           <a:xfrm>
             <a:off x="1005840" y="3246120"/>
-            <a:ext cx="4297680" cy="274320"/>
+            <a:ext cx="4389120" cy="274320"/>
           </a:xfrm>
           <a:prstGeom prst="rect">
             <a:avLst/>
@@ -6507,7 +6528,7 @@
           <a:noFill/>
         </p:spPr>
         <p:txBody>
-          <a:bodyPr wrap="none">
+          <a:bodyPr wrap="square">
             <a:spAutoFit/>
           </a:bodyPr>
           <a:lstStyle/>
@@ -6520,7 +6541,7 @@
                 </a:solidFill>
                 <a:latin typeface="Aptos"/>
               </a:rPr>
-              <a:t>custom visual states</a:t>
+              <a:t>estilos e estados visuais</a:t>
             </a:r>
           </a:p>
         </p:txBody>
@@ -6579,7 +6600,7 @@
         <p:spPr>
           <a:xfrm>
             <a:off x="6583679" y="2907792"/>
-            <a:ext cx="2194560" cy="274320"/>
+            <a:ext cx="2560320" cy="274320"/>
           </a:xfrm>
           <a:prstGeom prst="rect">
             <a:avLst/>
@@ -6587,7 +6608,7 @@
           <a:noFill/>
         </p:spPr>
         <p:txBody>
-          <a:bodyPr wrap="none">
+          <a:bodyPr wrap="square">
             <a:spAutoFit/>
           </a:bodyPr>
           <a:lstStyle/>
@@ -6600,7 +6621,7 @@
                 </a:solidFill>
                 <a:latin typeface="Aptos"/>
               </a:rPr>
-              <a:t>Tailwind</a:t>
+              <a:t>Tailwind CSS</a:t>
             </a:r>
           </a:p>
         </p:txBody>
@@ -6614,7 +6635,7 @@
         <p:spPr>
           <a:xfrm>
             <a:off x="6583679" y="3246120"/>
-            <a:ext cx="4297680" cy="274320"/>
+            <a:ext cx="4389120" cy="274320"/>
           </a:xfrm>
           <a:prstGeom prst="rect">
             <a:avLst/>
@@ -6622,7 +6643,7 @@
           <a:noFill/>
         </p:spPr>
         <p:txBody>
-          <a:bodyPr wrap="none">
+          <a:bodyPr wrap="square">
             <a:spAutoFit/>
           </a:bodyPr>
           <a:lstStyle/>
@@ -6635,7 +6656,7 @@
                 </a:solidFill>
                 <a:latin typeface="Aptos"/>
               </a:rPr>
-              <a:t>layout and design utilities</a:t>
+              <a:t>layout, espaçamentos e responsividade</a:t>
             </a:r>
           </a:p>
         </p:txBody>
@@ -6694,7 +6715,7 @@
         <p:spPr>
           <a:xfrm>
             <a:off x="1005840" y="4233672"/>
-            <a:ext cx="2194560" cy="274320"/>
+            <a:ext cx="2560320" cy="274320"/>
           </a:xfrm>
           <a:prstGeom prst="rect">
             <a:avLst/>
@@ -6702,7 +6723,7 @@
           <a:noFill/>
         </p:spPr>
         <p:txBody>
-          <a:bodyPr wrap="none">
+          <a:bodyPr wrap="square">
             <a:spAutoFit/>
           </a:bodyPr>
           <a:lstStyle/>
@@ -6729,7 +6750,7 @@
         <p:spPr>
           <a:xfrm>
             <a:off x="1005840" y="4572000"/>
-            <a:ext cx="4297680" cy="274320"/>
+            <a:ext cx="4389120" cy="274320"/>
           </a:xfrm>
           <a:prstGeom prst="rect">
             <a:avLst/>
@@ -6737,7 +6758,7 @@
           <a:noFill/>
         </p:spPr>
         <p:txBody>
-          <a:bodyPr wrap="none">
+          <a:bodyPr wrap="square">
             <a:spAutoFit/>
           </a:bodyPr>
           <a:lstStyle/>
@@ -6750,7 +6771,7 @@
                 </a:solidFill>
                 <a:latin typeface="Aptos"/>
               </a:rPr>
-              <a:t>algorithm and DOM interaction</a:t>
+              <a:t>algoritmo e interação com o DOM</a:t>
             </a:r>
           </a:p>
         </p:txBody>
@@ -6809,7 +6830,7 @@
         <p:spPr>
           <a:xfrm>
             <a:off x="6583679" y="4233672"/>
-            <a:ext cx="2194560" cy="274320"/>
+            <a:ext cx="2560320" cy="274320"/>
           </a:xfrm>
           <a:prstGeom prst="rect">
             <a:avLst/>
@@ -6817,7 +6838,7 @@
           <a:noFill/>
         </p:spPr>
         <p:txBody>
-          <a:bodyPr wrap="none">
+          <a:bodyPr wrap="square">
             <a:spAutoFit/>
           </a:bodyPr>
           <a:lstStyle/>
@@ -6844,7 +6865,7 @@
         <p:spPr>
           <a:xfrm>
             <a:off x="6583679" y="4572000"/>
-            <a:ext cx="4297680" cy="274320"/>
+            <a:ext cx="4389120" cy="274320"/>
           </a:xfrm>
           <a:prstGeom prst="rect">
             <a:avLst/>
@@ -6852,7 +6873,7 @@
           <a:noFill/>
         </p:spPr>
         <p:txBody>
-          <a:bodyPr wrap="none">
+          <a:bodyPr wrap="square">
             <a:spAutoFit/>
           </a:bodyPr>
           <a:lstStyle/>
@@ -6865,7 +6886,7 @@
                 </a:solidFill>
                 <a:latin typeface="Aptos"/>
               </a:rPr>
-              <a:t>version control and deployment</a:t>
+              <a:t>controlo de versões e publicação automática</a:t>
             </a:r>
           </a:p>
         </p:txBody>
@@ -6887,7 +6908,7 @@
           <a:noFill/>
         </p:spPr>
         <p:txBody>
-          <a:bodyPr wrap="none">
+          <a:bodyPr wrap="square">
             <a:spAutoFit/>
           </a:bodyPr>
           <a:lstStyle/>
@@ -6940,7 +6961,7 @@
         <p:spPr>
           <a:xfrm>
             <a:off x="685800" y="411480"/>
-            <a:ext cx="10698480" cy="548640"/>
+            <a:ext cx="10698480" cy="594360"/>
           </a:xfrm>
           <a:prstGeom prst="rect">
             <a:avLst/>
@@ -6948,7 +6969,7 @@
           <a:noFill/>
         </p:spPr>
         <p:txBody>
-          <a:bodyPr wrap="none">
+          <a:bodyPr wrap="square">
             <a:spAutoFit/>
           </a:bodyPr>
           <a:lstStyle/>
@@ -6961,7 +6982,7 @@
                 </a:solidFill>
                 <a:latin typeface="Aptos"/>
               </a:rPr>
-              <a:t>Code organization</a:t>
+              <a:t>Organização do código</a:t>
             </a:r>
           </a:p>
         </p:txBody>
@@ -6974,7 +6995,7 @@
         </p:nvSpPr>
         <p:spPr>
           <a:xfrm>
-            <a:off x="713232" y="1024128"/>
+            <a:off x="713232" y="1051560"/>
             <a:ext cx="10241280" cy="411480"/>
           </a:xfrm>
           <a:prstGeom prst="rect">
@@ -6983,7 +7004,7 @@
           <a:noFill/>
         </p:spPr>
         <p:txBody>
-          <a:bodyPr wrap="none">
+          <a:bodyPr wrap="square">
             <a:spAutoFit/>
           </a:bodyPr>
           <a:lstStyle/>
@@ -6996,7 +7017,7 @@
                 </a:solidFill>
                 <a:latin typeface="Aptos"/>
               </a:rPr>
-              <a:t>The algorithm is separated from the interface.</a:t>
+              <a:t>A lógica do algoritmo está separada da interface.</a:t>
             </a:r>
           </a:p>
         </p:txBody>
@@ -7018,7 +7039,7 @@
           <a:noFill/>
         </p:spPr>
         <p:txBody>
-          <a:bodyPr wrap="none">
+          <a:bodyPr wrap="square">
             <a:spAutoFit/>
           </a:bodyPr>
           <a:lstStyle/>
@@ -7070,7 +7091,7 @@
               </a:defRPr>
             </a:pPr>
             <a:r>
-              <a:t>Pure pathfinding logic</a:t>
+              <a:t>Lógica pura do algoritmo</a:t>
             </a:r>
           </a:p>
           <a:p>
@@ -7086,7 +7107,7 @@
               </a:defRPr>
             </a:pPr>
             <a:r>
-              <a:t>Valid map generation</a:t>
+              <a:t>Geração de mapas válidos</a:t>
             </a:r>
           </a:p>
           <a:p>
@@ -7102,7 +7123,7 @@
               </a:defRPr>
             </a:pPr>
             <a:r>
-              <a:t>A* route calculation</a:t>
+              <a:t>Cálculo da rota com A*</a:t>
             </a:r>
           </a:p>
         </p:txBody>
@@ -7124,7 +7145,7 @@
           <a:noFill/>
         </p:spPr>
         <p:txBody>
-          <a:bodyPr wrap="none">
+          <a:bodyPr wrap="square">
             <a:spAutoFit/>
           </a:bodyPr>
           <a:lstStyle/>
@@ -7176,7 +7197,7 @@
               </a:defRPr>
             </a:pPr>
             <a:r>
-              <a:t>Grid rendering</a:t>
+              <a:t>Desenho da grelha</a:t>
             </a:r>
           </a:p>
           <a:p>
@@ -7192,7 +7213,7 @@
               </a:defRPr>
             </a:pPr>
             <a:r>
-              <a:t>Button events</a:t>
+              <a:t>Eventos dos botões</a:t>
             </a:r>
           </a:p>
           <a:p>
@@ -7208,7 +7229,7 @@
               </a:defRPr>
             </a:pPr>
             <a:r>
-              <a:t>Animation and DOM updates</a:t>
+              <a:t>Animação e atualização do DOM</a:t>
             </a:r>
           </a:p>
         </p:txBody>
@@ -7222,7 +7243,7 @@
         <p:spPr>
           <a:xfrm>
             <a:off x="1280160" y="5074920"/>
-            <a:ext cx="9601200" cy="548640"/>
+            <a:ext cx="7863840" cy="548640"/>
           </a:xfrm>
           <a:prstGeom prst="roundRect">
             <a:avLst/>
@@ -7262,7 +7283,7 @@
                 </a:solidFill>
                 <a:latin typeface="Aptos"/>
               </a:rPr>
-              <a:t>This separation makes the code easier to explain during presentation.</a:t>
+              <a:t>Separar responsabilidades torna o código mais fácil de explicar.</a:t>
             </a:r>
           </a:p>
         </p:txBody>
@@ -7284,7 +7305,7 @@
           <a:noFill/>
         </p:spPr>
         <p:txBody>
-          <a:bodyPr wrap="none">
+          <a:bodyPr wrap="square">
             <a:spAutoFit/>
           </a:bodyPr>
           <a:lstStyle/>
@@ -7337,7 +7358,7 @@
         <p:spPr>
           <a:xfrm>
             <a:off x="685800" y="411480"/>
-            <a:ext cx="10698480" cy="548640"/>
+            <a:ext cx="10698480" cy="594360"/>
           </a:xfrm>
           <a:prstGeom prst="rect">
             <a:avLst/>
@@ -7345,7 +7366,7 @@
           <a:noFill/>
         </p:spPr>
         <p:txBody>
-          <a:bodyPr wrap="none">
+          <a:bodyPr wrap="square">
             <a:spAutoFit/>
           </a:bodyPr>
           <a:lstStyle/>
@@ -7358,7 +7379,7 @@
                 </a:solidFill>
                 <a:latin typeface="Aptos"/>
               </a:rPr>
-              <a:t>What the project demonstrates</a:t>
+              <a:t>O que o projeto demonstra</a:t>
             </a:r>
           </a:p>
         </p:txBody>
@@ -7397,7 +7418,7 @@
               </a:defRPr>
             </a:pPr>
             <a:r>
-              <a:t>A useful connection between programming and industrial robotics.</a:t>
+              <a:t>Programação aplicada a um contexto real de robótica.</a:t>
             </a:r>
           </a:p>
           <a:p>
@@ -7413,7 +7434,7 @@
               </a:defRPr>
             </a:pPr>
             <a:r>
-              <a:t>An algorithm with a visible result, not hidden theory.</a:t>
+              <a:t>Um algoritmo visível, com resultado no ecrã.</a:t>
             </a:r>
           </a:p>
           <a:p>
@@ -7429,7 +7450,7 @@
               </a:defRPr>
             </a:pPr>
             <a:r>
-              <a:t>Good code organization through components and separated logic.</a:t>
+              <a:t>Uso prático de HTML, CSS e JavaScript.</a:t>
             </a:r>
           </a:p>
           <a:p>
@@ -7445,7 +7466,7 @@
               </a:defRPr>
             </a:pPr>
             <a:r>
-              <a:t>A deployed website that can be accessed by anyone.</a:t>
+              <a:t>Componentes reutilizáveis em Astro.</a:t>
             </a:r>
           </a:p>
           <a:p>
@@ -7461,7 +7482,7 @@
               </a:defRPr>
             </a:pPr>
             <a:r>
-              <a:t>A final report available directly from the site.</a:t>
+              <a:t>Publicação online com GitHub e Cloudflare Pages.</a:t>
             </a:r>
           </a:p>
         </p:txBody>
@@ -7483,7 +7504,7 @@
           <a:noFill/>
         </p:spPr>
         <p:txBody>
-          <a:bodyPr wrap="none">
+          <a:bodyPr wrap="square">
             <a:spAutoFit/>
           </a:bodyPr>
           <a:lstStyle/>

</xml_diff>